<commit_message>
Refresh deck and gap analysis: closed gaps, backtest and smoke numbers
Co-Authored-By: Claude Sonnet 5.5 <noreply@anthropic.com>
Claude-Session: https://claude.ai/code/session_01YRwMuKya12nXYQ5WfztNQT
</commit_message>
<xml_diff>
--- a/_designs/deck/TransferHub-Hackathon.pptx
+++ b/_designs/deck/TransferHub-Hackathon.pptx
@@ -21,9 +21,10 @@
     <p:sldId id="269" r:id="rId15"/>
     <p:sldId id="270" r:id="rId16"/>
     <p:sldId id="271" r:id="rId17"/>
+    <p:sldId id="272" r:id="rId18"/>
   </p:sldIdLst>
   <p:notesMasterIdLst>
-    <p:notesMasterId r:id="rId18"/>
+    <p:notesMasterId r:id="rId19"/>
   </p:notesMasterIdLst>
   <p:sldSz cx="12192000" cy="6858000"/>
   <p:notesSz cx="6858000" cy="12192000"/>
@@ -311,13 +312,13 @@
               <c:numCache>
                 <c:ptCount val="3"/>
                 <c:pt idx="0">
-                  <c:v>17</c:v>
+                  <c:v>20</c:v>
                 </c:pt>
                 <c:pt idx="1">
-                  <c:v>3</c:v>
+                  <c:v>2</c:v>
                 </c:pt>
                 <c:pt idx="2">
-                  <c:v>2</c:v>
+                  <c:v>0</c:v>
                 </c:pt>
               </c:numCache>
             </c:numRef>
@@ -1203,7 +1204,7 @@
           <a:p>
             <a:r>
               <a:rPr lang="en-US" dirty="0"/>
-              <a:t>We compared every rule and ask in the design docs with the code. 17 built, 3 partial, 2 open. Full table in _designs/GAP_ANALYSIS.md.</a:t>
+              <a:t>Backtest: for each past decision (63), hide it from the matcher and ask whether the right BU course is in its top 1 or top 3. Built-in rules only, no AI key. Smoke suite ran against the live site.</a:t>
             </a:r>
             <a:endParaRPr lang="en-US" dirty="0"/>
           </a:p>
@@ -1291,7 +1292,7 @@
           <a:p>
             <a:r>
               <a:rPr lang="en-US" dirty="0"/>
-              <a:t>Be honest: no live Claude key, no BU baseline numbers. Plan to close the gaps.</a:t>
+              <a:t>We compared every rule and ask in the design docs with the code. 20 built, 2 partial, 0 open (the partials: a faculty picker for several BU courses, and the 5-credit lab rule that needs an answer from BU). Full table in _designs/GAP_ANALYSIS.md.</a:t>
             </a:r>
             <a:endParaRPr lang="en-US" dirty="0"/>
           </a:p>
@@ -1379,7 +1380,7 @@
           <a:p>
             <a:r>
               <a:rPr lang="en-US" dirty="0"/>
-              <a:t>Close on the promise and invite the live demo.</a:t>
+              <a:t>Be honest: no live Claude key, no BU baseline numbers. Plan to close the gaps.</a:t>
             </a:r>
             <a:endParaRPr lang="en-US" dirty="0"/>
           </a:p>
@@ -1403,6 +1404,94 @@
             <a:fld id="{F7021451-1387-4CA6-816F-3879F97B5CBC}" type="slidenum">
               <a:rPr lang="en-US"/>
               <a:t>16</a:t>
+            </a:fld>
+            <a:endParaRPr lang="en-US"/>
+          </a:p>
+        </p:txBody>
+      </p:sp>
+    </p:spTree>
+    <p:extLst>
+      <p:ext uri="{BB962C8B-B14F-4D97-AF65-F5344CB8AC3E}">
+        <p14:creationId xmlns:p14="http://schemas.microsoft.com/office/powerpoint/2010/main" val="1024086991"/>
+      </p:ext>
+    </p:extLst>
+  </p:cSld>
+  <p:clrMapOvr>
+    <a:masterClrMapping/>
+  </p:clrMapOvr>
+</p:notes>
+</file>
+
+<file path=ppt/notesSlides/notesSlide17.xml><?xml version="1.0" encoding="utf-8"?>
+<p:notes xmlns:a="http://schemas.openxmlformats.org/drawingml/2006/main" xmlns:r="http://schemas.openxmlformats.org/officeDocument/2006/relationships" xmlns:p="http://schemas.openxmlformats.org/presentationml/2006/main">
+  <p:cSld>
+    <p:spTree>
+      <p:nvGrpSpPr>
+        <p:cNvPr id="1" name=""/>
+        <p:cNvGrpSpPr/>
+        <p:nvPr/>
+      </p:nvGrpSpPr>
+      <p:grpSpPr>
+        <a:xfrm>
+          <a:off x="0" y="0"/>
+          <a:ext cx="0" cy="0"/>
+          <a:chOff x="0" y="0"/>
+          <a:chExt cx="0" cy="0"/>
+        </a:xfrm>
+      </p:grpSpPr>
+      <p:sp>
+        <p:nvSpPr>
+          <p:cNvPr id="2" name="Slide Image Placeholder 1"/>
+          <p:cNvSpPr>
+            <a:spLocks noGrp="1" noRot="1" noChangeAspect="1"/>
+          </p:cNvSpPr>
+          <p:nvPr>
+            <p:ph type="sldImg"/>
+          </p:nvPr>
+        </p:nvSpPr>
+        <p:spPr/>
+      </p:sp>
+      <p:sp>
+        <p:nvSpPr>
+          <p:cNvPr id="3" name="Notes Placeholder 2"/>
+          <p:cNvSpPr>
+            <a:spLocks noGrp="1"/>
+          </p:cNvSpPr>
+          <p:nvPr>
+            <p:ph type="body" idx="1"/>
+          </p:nvPr>
+        </p:nvSpPr>
+        <p:spPr/>
+        <p:txBody>
+          <a:bodyPr/>
+          <a:lstStyle/>
+          <a:p>
+            <a:r>
+              <a:rPr lang="en-US" dirty="0"/>
+              <a:t>Close on the promise and invite the live demo.</a:t>
+            </a:r>
+            <a:endParaRPr lang="en-US" dirty="0"/>
+          </a:p>
+        </p:txBody>
+      </p:sp>
+      <p:sp>
+        <p:nvSpPr>
+          <p:cNvPr id="4" name="Slide Number Placeholder 3"/>
+          <p:cNvSpPr>
+            <a:spLocks noGrp="1"/>
+          </p:cNvSpPr>
+          <p:nvPr>
+            <p:ph type="sldNum" sz="quarter" idx="10"/>
+          </p:nvPr>
+        </p:nvSpPr>
+        <p:spPr/>
+        <p:txBody>
+          <a:bodyPr/>
+          <a:lstStyle/>
+          <a:p>
+            <a:fld id="{F7021451-1387-4CA6-816F-3879F97B5CBC}" type="slidenum">
+              <a:rPr lang="en-US"/>
+              <a:t>17</a:t>
             </a:fld>
             <a:endParaRPr lang="en-US"/>
           </a:p>
@@ -5785,7 +5874,7 @@
                 <a:ea typeface="Cambria" pitchFamily="34" charset="-122"/>
                 <a:cs typeface="Cambria" pitchFamily="34" charset="-120"/>
               </a:rPr>
-              <a:t>Scorecard: 22 requirements vs. the code</a:t>
+              <a:t>Measured, not claimed</a:t>
             </a:r>
             <a:endParaRPr lang="en-US" sz="3400" dirty="0"/>
           </a:p>
@@ -5827,36 +5916,20 @@
           </a:p>
         </p:txBody>
       </p:sp>
-      <p:graphicFrame>
-        <p:nvGraphicFramePr>
-          <p:cNvPr id="5" name="Chart 0" descr=""/>
-          <p:cNvGraphicFramePr/>
-          <p:nvPr/>
-        </p:nvGraphicFramePr>
-        <p:xfrm>
-          <a:off x="548640" y="1371600"/>
-          <a:ext cx="4754880" cy="4480560"/>
-        </p:xfrm>
-        <a:graphic xmlns:a="http://schemas.openxmlformats.org/drawingml/2006/main">
-          <a:graphicData uri="http://schemas.openxmlformats.org/drawingml/2006/chart">
-            <c:chart xmlns:c="http://schemas.openxmlformats.org/drawingml/2006/chart" r:id="rId1"/>
-          </a:graphicData>
-        </a:graphic>
-      </p:graphicFrame>
-      <p:sp>
-        <p:nvSpPr>
-          <p:cNvPr id="6" name="Shape 2"/>
+      <p:sp>
+        <p:nvSpPr>
+          <p:cNvPr id="5" name="Shape 2"/>
           <p:cNvSpPr/>
           <p:nvPr/>
         </p:nvSpPr>
         <p:spPr>
           <a:xfrm>
-            <a:off x="5669280" y="1463040"/>
-            <a:ext cx="5943600" cy="1280160"/>
+            <a:off x="548640" y="1463040"/>
+            <a:ext cx="3566160" cy="2194560"/>
           </a:xfrm>
           <a:prstGeom prst="roundRect">
             <a:avLst>
-              <a:gd name="adj" fmla="val 8571"/>
+              <a:gd name="adj" fmla="val 5000"/>
             </a:avLst>
           </a:prstGeom>
           <a:solidFill>
@@ -5879,93 +5952,93 @@
       </p:sp>
       <p:sp>
         <p:nvSpPr>
-          <p:cNvPr id="7" name="Shape 3"/>
+          <p:cNvPr id="6" name="Text 3"/>
+          <p:cNvSpPr txBox="1"/>
+          <p:nvPr/>
+        </p:nvSpPr>
+        <p:spPr>
+          <a:xfrm>
+            <a:off x="548640" y="1645920"/>
+            <a:ext cx="3566160" cy="1188720"/>
+          </a:xfrm>
+          <a:prstGeom prst="rect">
+            <a:avLst/>
+          </a:prstGeom>
+          <a:noFill/>
+          <a:ln/>
+        </p:spPr>
+        <p:txBody>
+          <a:bodyPr wrap="square" lIns="0" tIns="0" rIns="0" bIns="0" rtlCol="0" anchor="ctr"/>
+          <a:lstStyle/>
+          <a:p>
+            <a:pPr algn="ctr" indent="0" marL="0">
+              <a:buNone/>
+            </a:pPr>
+            <a:r>
+              <a:rPr lang="en-US" sz="6000" b="1" dirty="0">
+                <a:solidFill>
+                  <a:srgbClr val="770816"/>
+                </a:solidFill>
+                <a:latin typeface="Cambria" pitchFamily="34" charset="0"/>
+                <a:ea typeface="Cambria" pitchFamily="34" charset="-122"/>
+                <a:cs typeface="Cambria" pitchFamily="34" charset="-120"/>
+              </a:rPr>
+              <a:t>96.8%</a:t>
+            </a:r>
+            <a:endParaRPr lang="en-US" sz="6000" dirty="0"/>
+          </a:p>
+        </p:txBody>
+      </p:sp>
+      <p:sp>
+        <p:nvSpPr>
+          <p:cNvPr id="7" name="Text 4"/>
+          <p:cNvSpPr txBox="1"/>
+          <p:nvPr/>
+        </p:nvSpPr>
+        <p:spPr>
+          <a:xfrm>
+            <a:off x="731520" y="2880360"/>
+            <a:ext cx="3200400" cy="640080"/>
+          </a:xfrm>
+          <a:prstGeom prst="rect">
+            <a:avLst/>
+          </a:prstGeom>
+          <a:noFill/>
+          <a:ln/>
+        </p:spPr>
+        <p:txBody>
+          <a:bodyPr wrap="square" lIns="0" tIns="0" rIns="0" bIns="0" rtlCol="0" anchor="ctr"/>
+          <a:lstStyle/>
+          <a:p>
+            <a:pPr algn="ctr" indent="0" marL="0">
+              <a:buNone/>
+            </a:pPr>
+            <a:r>
+              <a:rPr lang="en-US" sz="1600" dirty="0">
+                <a:solidFill>
+                  <a:srgbClr val="2B1A1D"/>
+                </a:solidFill>
+              </a:rPr>
+              <a:t>right BU course in the top 3</a:t>
+            </a:r>
+            <a:endParaRPr lang="en-US" sz="1600" dirty="0"/>
+          </a:p>
+        </p:txBody>
+      </p:sp>
+      <p:sp>
+        <p:nvSpPr>
+          <p:cNvPr id="8" name="Shape 5"/>
           <p:cNvSpPr/>
           <p:nvPr/>
         </p:nvSpPr>
         <p:spPr>
           <a:xfrm>
-            <a:off x="5897880" y="1920240"/>
-            <a:ext cx="365760" cy="365760"/>
-          </a:xfrm>
-          <a:prstGeom prst="ellipse">
-            <a:avLst/>
-          </a:prstGeom>
-          <a:solidFill>
-            <a:srgbClr val="B3261E"/>
-          </a:solidFill>
-          <a:ln w="12700">
-            <a:solidFill>
-              <a:srgbClr val="B3261E"/>
-            </a:solidFill>
-            <a:prstDash val="solid"/>
-          </a:ln>
-        </p:spPr>
-      </p:sp>
-      <p:sp>
-        <p:nvSpPr>
-          <p:cNvPr id="8" name="Text 4"/>
-          <p:cNvSpPr txBox="1"/>
-          <p:nvPr/>
-        </p:nvSpPr>
-        <p:spPr>
-          <a:xfrm>
-            <a:off x="6446520" y="1463040"/>
-            <a:ext cx="5029200" cy="1280160"/>
-          </a:xfrm>
-          <a:prstGeom prst="rect">
-            <a:avLst/>
-          </a:prstGeom>
-          <a:noFill/>
-          <a:ln/>
-        </p:spPr>
-        <p:txBody>
-          <a:bodyPr wrap="square" lIns="0" tIns="0" rIns="0" bIns="0" rtlCol="0" anchor="ctr"/>
-          <a:lstStyle/>
-          <a:p>
-            <a:pPr indent="0" marL="0">
-              <a:buNone/>
-            </a:pPr>
-            <a:r>
-              <a:rPr lang="en-US" sz="1800" b="1" dirty="0">
-                <a:solidFill>
-                  <a:srgbClr val="B3261E"/>
-                </a:solidFill>
-              </a:rPr>
-              <a:t>Open</a:t>
-            </a:r>
-            <a:endParaRPr lang="en-US" sz="1800" dirty="0"/>
-          </a:p>
-          <a:p>
-            <a:pPr indent="0" marL="0">
-              <a:buNone/>
-            </a:pPr>
-            <a:r>
-              <a:rPr lang="en-US" sz="1300" dirty="0">
-                <a:solidFill>
-                  <a:srgbClr val="2B1A1D"/>
-                </a:solidFill>
-              </a:rPr>
-              <a:t>One-year deadline tracker · programme rules (Econ/Bio caps, substitutions)</a:t>
-            </a:r>
-            <a:endParaRPr lang="en-US" sz="1800" dirty="0"/>
-          </a:p>
-        </p:txBody>
-      </p:sp>
-      <p:sp>
-        <p:nvSpPr>
-          <p:cNvPr id="9" name="Shape 5"/>
-          <p:cNvSpPr/>
-          <p:nvPr/>
-        </p:nvSpPr>
-        <p:spPr>
-          <a:xfrm>
-            <a:off x="5669280" y="2926080"/>
-            <a:ext cx="5943600" cy="1280160"/>
+            <a:off x="4297680" y="1463040"/>
+            <a:ext cx="3566160" cy="2194560"/>
           </a:xfrm>
           <a:prstGeom prst="roundRect">
             <a:avLst>
-              <a:gd name="adj" fmla="val 8571"/>
+              <a:gd name="adj" fmla="val 5000"/>
             </a:avLst>
           </a:prstGeom>
           <a:solidFill>
@@ -5988,93 +6061,93 @@
       </p:sp>
       <p:sp>
         <p:nvSpPr>
-          <p:cNvPr id="10" name="Shape 6"/>
+          <p:cNvPr id="9" name="Text 6"/>
+          <p:cNvSpPr txBox="1"/>
+          <p:nvPr/>
+        </p:nvSpPr>
+        <p:spPr>
+          <a:xfrm>
+            <a:off x="4297680" y="1645920"/>
+            <a:ext cx="3566160" cy="1188720"/>
+          </a:xfrm>
+          <a:prstGeom prst="rect">
+            <a:avLst/>
+          </a:prstGeom>
+          <a:noFill/>
+          <a:ln/>
+        </p:spPr>
+        <p:txBody>
+          <a:bodyPr wrap="square" lIns="0" tIns="0" rIns="0" bIns="0" rtlCol="0" anchor="ctr"/>
+          <a:lstStyle/>
+          <a:p>
+            <a:pPr algn="ctr" indent="0" marL="0">
+              <a:buNone/>
+            </a:pPr>
+            <a:r>
+              <a:rPr lang="en-US" sz="6000" b="1" dirty="0">
+                <a:solidFill>
+                  <a:srgbClr val="770816"/>
+                </a:solidFill>
+                <a:latin typeface="Cambria" pitchFamily="34" charset="0"/>
+                <a:ea typeface="Cambria" pitchFamily="34" charset="-122"/>
+                <a:cs typeface="Cambria" pitchFamily="34" charset="-120"/>
+              </a:rPr>
+              <a:t>88.9%</a:t>
+            </a:r>
+            <a:endParaRPr lang="en-US" sz="6000" dirty="0"/>
+          </a:p>
+        </p:txBody>
+      </p:sp>
+      <p:sp>
+        <p:nvSpPr>
+          <p:cNvPr id="10" name="Text 7"/>
+          <p:cNvSpPr txBox="1"/>
+          <p:nvPr/>
+        </p:nvSpPr>
+        <p:spPr>
+          <a:xfrm>
+            <a:off x="4480560" y="2880360"/>
+            <a:ext cx="3200400" cy="640080"/>
+          </a:xfrm>
+          <a:prstGeom prst="rect">
+            <a:avLst/>
+          </a:prstGeom>
+          <a:noFill/>
+          <a:ln/>
+        </p:spPr>
+        <p:txBody>
+          <a:bodyPr wrap="square" lIns="0" tIns="0" rIns="0" bIns="0" rtlCol="0" anchor="ctr"/>
+          <a:lstStyle/>
+          <a:p>
+            <a:pPr algn="ctr" indent="0" marL="0">
+              <a:buNone/>
+            </a:pPr>
+            <a:r>
+              <a:rPr lang="en-US" sz="1600" dirty="0">
+                <a:solidFill>
+                  <a:srgbClr val="2B1A1D"/>
+                </a:solidFill>
+              </a:rPr>
+              <a:t>right BU course ranked first</a:t>
+            </a:r>
+            <a:endParaRPr lang="en-US" sz="1600" dirty="0"/>
+          </a:p>
+        </p:txBody>
+      </p:sp>
+      <p:sp>
+        <p:nvSpPr>
+          <p:cNvPr id="11" name="Shape 8"/>
           <p:cNvSpPr/>
           <p:nvPr/>
         </p:nvSpPr>
         <p:spPr>
           <a:xfrm>
-            <a:off x="5897880" y="3383280"/>
-            <a:ext cx="365760" cy="365760"/>
-          </a:xfrm>
-          <a:prstGeom prst="ellipse">
-            <a:avLst/>
-          </a:prstGeom>
-          <a:solidFill>
-            <a:srgbClr val="C98A1B"/>
-          </a:solidFill>
-          <a:ln w="12700">
-            <a:solidFill>
-              <a:srgbClr val="C98A1B"/>
-            </a:solidFill>
-            <a:prstDash val="solid"/>
-          </a:ln>
-        </p:spPr>
-      </p:sp>
-      <p:sp>
-        <p:nvSpPr>
-          <p:cNvPr id="11" name="Text 7"/>
-          <p:cNvSpPr txBox="1"/>
-          <p:nvPr/>
-        </p:nvSpPr>
-        <p:spPr>
-          <a:xfrm>
-            <a:off x="6446520" y="2926080"/>
-            <a:ext cx="5029200" cy="1280160"/>
-          </a:xfrm>
-          <a:prstGeom prst="rect">
-            <a:avLst/>
-          </a:prstGeom>
-          <a:noFill/>
-          <a:ln/>
-        </p:spPr>
-        <p:txBody>
-          <a:bodyPr wrap="square" lIns="0" tIns="0" rIns="0" bIns="0" rtlCol="0" anchor="ctr"/>
-          <a:lstStyle/>
-          <a:p>
-            <a:pPr indent="0" marL="0">
-              <a:buNone/>
-            </a:pPr>
-            <a:r>
-              <a:rPr lang="en-US" sz="1800" b="1" dirty="0">
-                <a:solidFill>
-                  <a:srgbClr val="C98A1B"/>
-                </a:solidFill>
-              </a:rPr>
-              <a:t>Partial</a:t>
-            </a:r>
-            <a:endParaRPr lang="en-US" sz="1800" dirty="0"/>
-          </a:p>
-          <a:p>
-            <a:pPr indent="0" marL="0">
-              <a:buNone/>
-            </a:pPr>
-            <a:r>
-              <a:rPr lang="en-US" sz="1300" dirty="0">
-                <a:solidFill>
-                  <a:srgbClr val="2B1A1D"/>
-                </a:solidFill>
-              </a:rPr>
-              <a:t>Side-by-side course diff · one-to-many mappings · 5-credit lab rule (BU to confirm)</a:t>
-            </a:r>
-            <a:endParaRPr lang="en-US" sz="1800" dirty="0"/>
-          </a:p>
-        </p:txBody>
-      </p:sp>
-      <p:sp>
-        <p:nvSpPr>
-          <p:cNvPr id="12" name="Shape 8"/>
-          <p:cNvSpPr/>
-          <p:nvPr/>
-        </p:nvSpPr>
-        <p:spPr>
-          <a:xfrm>
-            <a:off x="5669280" y="4389120"/>
-            <a:ext cx="5943600" cy="1280160"/>
+            <a:off x="8046720" y="1463040"/>
+            <a:ext cx="3566160" cy="2194560"/>
           </a:xfrm>
           <a:prstGeom prst="roundRect">
             <a:avLst>
-              <a:gd name="adj" fmla="val 8571"/>
+              <a:gd name="adj" fmla="val 5000"/>
             </a:avLst>
           </a:prstGeom>
           <a:solidFill>
@@ -6097,76 +6170,217 @@
       </p:sp>
       <p:sp>
         <p:nvSpPr>
-          <p:cNvPr id="13" name="Shape 9"/>
-          <p:cNvSpPr/>
-          <p:nvPr/>
-        </p:nvSpPr>
-        <p:spPr>
-          <a:xfrm>
-            <a:off x="5897880" y="4846320"/>
-            <a:ext cx="365760" cy="365760"/>
-          </a:xfrm>
-          <a:prstGeom prst="ellipse">
-            <a:avLst/>
-          </a:prstGeom>
-          <a:solidFill>
-            <a:srgbClr val="2F7D5B"/>
-          </a:solidFill>
-          <a:ln w="12700">
-            <a:solidFill>
-              <a:srgbClr val="2F7D5B"/>
-            </a:solidFill>
-            <a:prstDash val="solid"/>
-          </a:ln>
-        </p:spPr>
-      </p:sp>
-      <p:sp>
-        <p:nvSpPr>
-          <p:cNvPr id="14" name="Text 10"/>
-          <p:cNvSpPr txBox="1"/>
-          <p:nvPr/>
-        </p:nvSpPr>
-        <p:spPr>
-          <a:xfrm>
-            <a:off x="6446520" y="4389120"/>
-            <a:ext cx="5029200" cy="1280160"/>
-          </a:xfrm>
-          <a:prstGeom prst="rect">
-            <a:avLst/>
-          </a:prstGeom>
-          <a:noFill/>
-          <a:ln/>
-        </p:spPr>
-        <p:txBody>
-          <a:bodyPr wrap="square" lIns="0" tIns="0" rIns="0" bIns="0" rtlCol="0" anchor="ctr"/>
-          <a:lstStyle/>
-          <a:p>
-            <a:pPr indent="0" marL="0">
-              <a:buNone/>
-            </a:pPr>
-            <a:r>
-              <a:rPr lang="en-US" sz="1800" b="1" dirty="0">
-                <a:solidFill>
-                  <a:srgbClr val="2F7D5B"/>
-                </a:solidFill>
-              </a:rPr>
-              <a:t>Built</a:t>
-            </a:r>
-            <a:endParaRPr lang="en-US" sz="1800" dirty="0"/>
-          </a:p>
-          <a:p>
-            <a:pPr indent="0" marL="0">
-              <a:buNone/>
-            </a:pPr>
-            <a:r>
-              <a:rPr lang="en-US" sz="1300" dirty="0">
+          <p:cNvPr id="12" name="Text 9"/>
+          <p:cNvSpPr txBox="1"/>
+          <p:nvPr/>
+        </p:nvSpPr>
+        <p:spPr>
+          <a:xfrm>
+            <a:off x="8046720" y="1645920"/>
+            <a:ext cx="3566160" cy="1188720"/>
+          </a:xfrm>
+          <a:prstGeom prst="rect">
+            <a:avLst/>
+          </a:prstGeom>
+          <a:noFill/>
+          <a:ln/>
+        </p:spPr>
+        <p:txBody>
+          <a:bodyPr wrap="square" lIns="0" tIns="0" rIns="0" bIns="0" rtlCol="0" anchor="ctr"/>
+          <a:lstStyle/>
+          <a:p>
+            <a:pPr algn="ctr" indent="0" marL="0">
+              <a:buNone/>
+            </a:pPr>
+            <a:r>
+              <a:rPr lang="en-US" sz="6000" b="1" dirty="0">
+                <a:solidFill>
+                  <a:srgbClr val="3A040B"/>
+                </a:solidFill>
+                <a:latin typeface="Cambria" pitchFamily="34" charset="0"/>
+                <a:ea typeface="Cambria" pitchFamily="34" charset="-122"/>
+                <a:cs typeface="Cambria" pitchFamily="34" charset="-120"/>
+              </a:rPr>
+              <a:t>63</a:t>
+            </a:r>
+            <a:endParaRPr lang="en-US" sz="6000" dirty="0"/>
+          </a:p>
+        </p:txBody>
+      </p:sp>
+      <p:sp>
+        <p:nvSpPr>
+          <p:cNvPr id="13" name="Text 10"/>
+          <p:cNvSpPr txBox="1"/>
+          <p:nvPr/>
+        </p:nvSpPr>
+        <p:spPr>
+          <a:xfrm>
+            <a:off x="8229600" y="2880360"/>
+            <a:ext cx="3200400" cy="640080"/>
+          </a:xfrm>
+          <a:prstGeom prst="rect">
+            <a:avLst/>
+          </a:prstGeom>
+          <a:noFill/>
+          <a:ln/>
+        </p:spPr>
+        <p:txBody>
+          <a:bodyPr wrap="square" lIns="0" tIns="0" rIns="0" bIns="0" rtlCol="0" anchor="ctr"/>
+          <a:lstStyle/>
+          <a:p>
+            <a:pPr algn="ctr" indent="0" marL="0">
+              <a:buNone/>
+            </a:pPr>
+            <a:r>
+              <a:rPr lang="en-US" sz="1600" dirty="0">
                 <a:solidFill>
                   <a:srgbClr val="2B1A1D"/>
                 </a:solidFill>
               </a:rPr>
-              <a:t>Lanes, quarter 2/3, grade rules, BU caps, Hub, appeals, workflow, learning loop, degree progress, accuracy backtest, Maya demo data</a:t>
-            </a:r>
-            <a:endParaRPr lang="en-US" sz="1800" dirty="0"/>
+              <a:t>past decisions tested</a:t>
+            </a:r>
+            <a:endParaRPr lang="en-US" sz="1600" dirty="0"/>
+          </a:p>
+        </p:txBody>
+      </p:sp>
+      <p:sp>
+        <p:nvSpPr>
+          <p:cNvPr id="14" name="Text 11"/>
+          <p:cNvSpPr txBox="1"/>
+          <p:nvPr/>
+        </p:nvSpPr>
+        <p:spPr>
+          <a:xfrm>
+            <a:off x="548640" y="3977640"/>
+            <a:ext cx="11064240" cy="731520"/>
+          </a:xfrm>
+          <a:prstGeom prst="rect">
+            <a:avLst/>
+          </a:prstGeom>
+          <a:noFill/>
+          <a:ln/>
+        </p:spPr>
+        <p:txBody>
+          <a:bodyPr wrap="square" lIns="0" tIns="0" rIns="0" bIns="0" rtlCol="0" anchor="ctr"/>
+          <a:lstStyle/>
+          <a:p>
+            <a:pPr indent="0" marL="0">
+              <a:buNone/>
+            </a:pPr>
+            <a:r>
+              <a:rPr lang="en-US" sz="1400" b="1" dirty="0">
+                <a:solidFill>
+                  <a:srgbClr val="770816"/>
+                </a:solidFill>
+              </a:rPr>
+              <a:t>Live smoke test  </a:t>
+            </a:r>
+            <a:pPr indent="0" marL="0">
+              <a:buNone/>
+            </a:pPr>
+            <a:r>
+              <a:rPr lang="en-US" sz="1400" dirty="0">
+                <a:solidFill>
+                  <a:srgbClr val="2B1A1D"/>
+                </a:solidFill>
+              </a:rPr>
+              <a:t>39 of 40 checks pass on the deployed app, 1 skipped (a write check), 0 failed: logins for all five roles, dashboards, the Maya scenario with the 2.66 quarter conversion, transfers, backtest, permissions and role checks.</a:t>
+            </a:r>
+            <a:endParaRPr lang="en-US" sz="1400" dirty="0"/>
+          </a:p>
+        </p:txBody>
+      </p:sp>
+      <p:sp>
+        <p:nvSpPr>
+          <p:cNvPr id="15" name="Text 12"/>
+          <p:cNvSpPr txBox="1"/>
+          <p:nvPr/>
+        </p:nvSpPr>
+        <p:spPr>
+          <a:xfrm>
+            <a:off x="548640" y="4754880"/>
+            <a:ext cx="11064240" cy="731520"/>
+          </a:xfrm>
+          <a:prstGeom prst="rect">
+            <a:avLst/>
+          </a:prstGeom>
+          <a:noFill/>
+          <a:ln/>
+        </p:spPr>
+        <p:txBody>
+          <a:bodyPr wrap="square" lIns="0" tIns="0" rIns="0" bIns="0" rtlCol="0" anchor="ctr"/>
+          <a:lstStyle/>
+          <a:p>
+            <a:pPr indent="0" marL="0">
+              <a:buNone/>
+            </a:pPr>
+            <a:r>
+              <a:rPr lang="en-US" sz="1400" b="1" dirty="0">
+                <a:solidFill>
+                  <a:srgbClr val="770816"/>
+                </a:solidFill>
+              </a:rPr>
+              <a:t>Database checks  </a:t>
+            </a:r>
+            <a:pPr indent="0" marL="0">
+              <a:buNone/>
+            </a:pPr>
+            <a:r>
+              <a:rPr lang="en-US" sz="1400" dirty="0">
+                <a:solidFill>
+                  <a:srgbClr val="2B1A1D"/>
+                </a:solidFill>
+              </a:rPr>
+              <a:t>243 SQL checks pass and all 11 triage contract cases pass, including the quarter 2.66 rule and "must be taken at BU".</a:t>
+            </a:r>
+            <a:endParaRPr lang="en-US" sz="1400" dirty="0"/>
+          </a:p>
+        </p:txBody>
+      </p:sp>
+      <p:sp>
+        <p:nvSpPr>
+          <p:cNvPr id="16" name="Text 13"/>
+          <p:cNvSpPr txBox="1"/>
+          <p:nvPr/>
+        </p:nvSpPr>
+        <p:spPr>
+          <a:xfrm>
+            <a:off x="548640" y="5532120"/>
+            <a:ext cx="11064240" cy="731520"/>
+          </a:xfrm>
+          <a:prstGeom prst="rect">
+            <a:avLst/>
+          </a:prstGeom>
+          <a:noFill/>
+          <a:ln/>
+        </p:spPr>
+        <p:txBody>
+          <a:bodyPr wrap="square" lIns="0" tIns="0" rIns="0" bIns="0" rtlCol="0" anchor="ctr"/>
+          <a:lstStyle/>
+          <a:p>
+            <a:pPr indent="0" marL="0">
+              <a:buNone/>
+            </a:pPr>
+            <a:r>
+              <a:rPr lang="en-US" sz="1400" b="1" dirty="0">
+                <a:solidFill>
+                  <a:srgbClr val="770816"/>
+                </a:solidFill>
+              </a:rPr>
+              <a:t>What this is  </a:t>
+            </a:r>
+            <a:pPr indent="0" marL="0">
+              <a:buNone/>
+            </a:pPr>
+            <a:r>
+              <a:rPr lang="en-US" sz="1400" dirty="0">
+                <a:solidFill>
+                  <a:srgbClr val="2B1A1D"/>
+                </a:solidFill>
+              </a:rPr>
+              <a:t>A hold-out test of the built-in rules matcher on past equivalencies. The same harness will score Claude once the key arrives.</a:t>
+            </a:r>
+            <a:endParaRPr lang="en-US" sz="1400" dirty="0"/>
           </a:p>
         </p:txBody>
       </p:sp>
@@ -6235,7 +6449,7 @@
                 <a:ea typeface="Cambria" pitchFamily="34" charset="-122"/>
                 <a:cs typeface="Cambria" pitchFamily="34" charset="-120"/>
               </a:rPr>
-              <a:t>What we have not proven yet, and what comes next</a:t>
+              <a:t>Scorecard: 22 requirements vs. the code</a:t>
             </a:r>
             <a:endParaRPr lang="en-US" sz="3400" dirty="0"/>
           </a:p>
@@ -6277,192 +6491,36 @@
           </a:p>
         </p:txBody>
       </p:sp>
-      <p:sp>
-        <p:nvSpPr>
-          <p:cNvPr id="5" name="Text 2"/>
-          <p:cNvSpPr txBox="1"/>
-          <p:nvPr/>
-        </p:nvSpPr>
-        <p:spPr>
-          <a:xfrm>
-            <a:off x="548640" y="1417320"/>
-            <a:ext cx="5303520" cy="457200"/>
-          </a:xfrm>
-          <a:prstGeom prst="rect">
-            <a:avLst/>
-          </a:prstGeom>
-          <a:noFill/>
-          <a:ln/>
-        </p:spPr>
-        <p:txBody>
-          <a:bodyPr wrap="square" lIns="0" tIns="0" rIns="0" bIns="0" rtlCol="0" anchor="ctr"/>
-          <a:lstStyle/>
-          <a:p>
-            <a:pPr indent="0" marL="0">
-              <a:buNone/>
-            </a:pPr>
-            <a:r>
-              <a:rPr lang="en-US" sz="2200" b="1" dirty="0">
-                <a:solidFill>
-                  <a:srgbClr val="770816"/>
-                </a:solidFill>
-                <a:latin typeface="Cambria" pitchFamily="34" charset="0"/>
-                <a:ea typeface="Cambria" pitchFamily="34" charset="-122"/>
-                <a:cs typeface="Cambria" pitchFamily="34" charset="-120"/>
-              </a:rPr>
-              <a:t>Not proven yet</a:t>
-            </a:r>
-            <a:endParaRPr lang="en-US" sz="2200" dirty="0"/>
-          </a:p>
-        </p:txBody>
-      </p:sp>
-      <p:sp>
-        <p:nvSpPr>
-          <p:cNvPr id="6" name="Text 3"/>
-          <p:cNvSpPr txBox="1"/>
-          <p:nvPr/>
-        </p:nvSpPr>
-        <p:spPr>
-          <a:xfrm>
-            <a:off x="548640" y="1965960"/>
-            <a:ext cx="5303520" cy="4023360"/>
-          </a:xfrm>
-          <a:prstGeom prst="rect">
-            <a:avLst/>
-          </a:prstGeom>
-          <a:noFill/>
-          <a:ln/>
-        </p:spPr>
-        <p:txBody>
-          <a:bodyPr wrap="square" lIns="0" tIns="0" rIns="0" bIns="0" rtlCol="0" anchor="t"/>
-          <a:lstStyle/>
-          <a:p>
-            <a:pPr marL="342900" indent="-342900">
-              <a:spcAft>
-                <a:spcPts val="1000"/>
-              </a:spcAft>
-              <a:buSzPct val="100000"/>
-              <a:buChar char="•"/>
-            </a:pPr>
-            <a:r>
-              <a:rPr lang="en-US" sz="1600" dirty="0">
-                <a:solidFill>
-                  <a:srgbClr val="2B1A1D"/>
-                </a:solidFill>
-              </a:rPr>
-              <a:t>No Anthropic key yet: AI paths are unverified, the rules fallback carries the demo</a:t>
-            </a:r>
-            <a:endParaRPr lang="en-US" sz="1600" dirty="0"/>
-          </a:p>
-          <a:p>
-            <a:pPr marL="342900" indent="-342900">
-              <a:spcAft>
-                <a:spcPts val="1000"/>
-              </a:spcAft>
-              <a:buSzPct val="100000"/>
-              <a:buChar char="•"/>
-            </a:pPr>
-            <a:r>
-              <a:rPr lang="en-US" sz="1600" dirty="0">
-                <a:solidFill>
-                  <a:srgbClr val="2B1A1D"/>
-                </a:solidFill>
-              </a:rPr>
-              <a:t>No BU baseline for evaluator minutes or turnaround, so the saving is not yet quantified</a:t>
-            </a:r>
-            <a:endParaRPr lang="en-US" sz="1600" dirty="0"/>
-          </a:p>
-          <a:p>
-            <a:pPr marL="342900" indent="-342900">
-              <a:spcAft>
-                <a:spcPts val="1000"/>
-              </a:spcAft>
-              <a:buSzPct val="100000"/>
-              <a:buChar char="•"/>
-            </a:pPr>
-            <a:r>
-              <a:rPr lang="en-US" sz="1600" dirty="0">
-                <a:solidFill>
-                  <a:srgbClr val="2B1A1D"/>
-                </a:solidFill>
-              </a:rPr>
-              <a:t>SQL logic was written and reviewed but has no automated tests</a:t>
-            </a:r>
-            <a:endParaRPr lang="en-US" sz="1600" dirty="0"/>
-          </a:p>
-          <a:p>
-            <a:pPr marL="342900" indent="-342900">
-              <a:spcAft>
-                <a:spcPts val="1000"/>
-              </a:spcAft>
-              <a:buSzPct val="100000"/>
-              <a:buChar char="•"/>
-            </a:pPr>
-            <a:r>
-              <a:rPr lang="en-US" sz="1600" dirty="0">
-                <a:solidFill>
-                  <a:srgbClr val="2B1A1D"/>
-                </a:solidFill>
-              </a:rPr>
-              <a:t>Quarter rounding (2.66) follows the brief; BU to confirm</a:t>
-            </a:r>
-            <a:endParaRPr lang="en-US" sz="1600" dirty="0"/>
-          </a:p>
-        </p:txBody>
-      </p:sp>
-      <p:sp>
-        <p:nvSpPr>
-          <p:cNvPr id="7" name="Text 4"/>
-          <p:cNvSpPr txBox="1"/>
-          <p:nvPr/>
-        </p:nvSpPr>
-        <p:spPr>
-          <a:xfrm>
-            <a:off x="6309360" y="1417320"/>
-            <a:ext cx="5303520" cy="457200"/>
-          </a:xfrm>
-          <a:prstGeom prst="rect">
-            <a:avLst/>
-          </a:prstGeom>
-          <a:noFill/>
-          <a:ln/>
-        </p:spPr>
-        <p:txBody>
-          <a:bodyPr wrap="square" lIns="0" tIns="0" rIns="0" bIns="0" rtlCol="0" anchor="ctr"/>
-          <a:lstStyle/>
-          <a:p>
-            <a:pPr indent="0" marL="0">
-              <a:buNone/>
-            </a:pPr>
-            <a:r>
-              <a:rPr lang="en-US" sz="2200" b="1" dirty="0">
-                <a:solidFill>
-                  <a:srgbClr val="770816"/>
-                </a:solidFill>
-                <a:latin typeface="Cambria" pitchFamily="34" charset="0"/>
-                <a:ea typeface="Cambria" pitchFamily="34" charset="-122"/>
-                <a:cs typeface="Cambria" pitchFamily="34" charset="-120"/>
-              </a:rPr>
-              <a:t>Next</a:t>
-            </a:r>
-            <a:endParaRPr lang="en-US" sz="2200" dirty="0"/>
-          </a:p>
-        </p:txBody>
-      </p:sp>
-      <p:sp>
-        <p:nvSpPr>
-          <p:cNvPr id="8" name="Shape 5"/>
+      <p:graphicFrame>
+        <p:nvGraphicFramePr>
+          <p:cNvPr id="5" name="Chart 0" descr=""/>
+          <p:cNvGraphicFramePr/>
+          <p:nvPr/>
+        </p:nvGraphicFramePr>
+        <p:xfrm>
+          <a:off x="548640" y="1371600"/>
+          <a:ext cx="4754880" cy="4480560"/>
+        </p:xfrm>
+        <a:graphic xmlns:a="http://schemas.openxmlformats.org/drawingml/2006/main">
+          <a:graphicData uri="http://schemas.openxmlformats.org/drawingml/2006/chart">
+            <c:chart xmlns:c="http://schemas.openxmlformats.org/drawingml/2006/chart" r:id="rId1"/>
+          </a:graphicData>
+        </a:graphic>
+      </p:graphicFrame>
+      <p:sp>
+        <p:nvSpPr>
+          <p:cNvPr id="6" name="Shape 2"/>
           <p:cNvSpPr/>
           <p:nvPr/>
         </p:nvSpPr>
         <p:spPr>
           <a:xfrm>
-            <a:off x="6309360" y="2011680"/>
-            <a:ext cx="5303520" cy="658368"/>
+            <a:off x="5669280" y="1463040"/>
+            <a:ext cx="5943600" cy="1280160"/>
           </a:xfrm>
           <a:prstGeom prst="roundRect">
             <a:avLst>
-              <a:gd name="adj" fmla="val 16667"/>
+              <a:gd name="adj" fmla="val 8571"/>
             </a:avLst>
           </a:prstGeom>
           <a:solidFill>
@@ -6485,93 +6543,93 @@
       </p:sp>
       <p:sp>
         <p:nvSpPr>
-          <p:cNvPr id="9" name="Text 6"/>
-          <p:cNvSpPr txBox="1"/>
-          <p:nvPr/>
-        </p:nvSpPr>
-        <p:spPr>
-          <a:xfrm>
-            <a:off x="6446520" y="2011680"/>
-            <a:ext cx="457200" cy="658368"/>
-          </a:xfrm>
-          <a:prstGeom prst="rect">
-            <a:avLst/>
-          </a:prstGeom>
-          <a:noFill/>
-          <a:ln/>
-        </p:spPr>
-        <p:txBody>
-          <a:bodyPr wrap="square" lIns="0" tIns="0" rIns="0" bIns="0" rtlCol="0" anchor="ctr"/>
-          <a:lstStyle/>
-          <a:p>
-            <a:pPr indent="0" marL="0">
-              <a:buNone/>
-            </a:pPr>
-            <a:r>
-              <a:rPr lang="en-US" sz="2200" b="1" dirty="0">
-                <a:solidFill>
-                  <a:srgbClr val="D9A441"/>
-                </a:solidFill>
-                <a:latin typeface="Cambria" pitchFamily="34" charset="0"/>
-                <a:ea typeface="Cambria" pitchFamily="34" charset="-122"/>
-                <a:cs typeface="Cambria" pitchFamily="34" charset="-120"/>
-              </a:rPr>
-              <a:t>1</a:t>
-            </a:r>
-            <a:endParaRPr lang="en-US" sz="2200" dirty="0"/>
-          </a:p>
-        </p:txBody>
-      </p:sp>
-      <p:sp>
-        <p:nvSpPr>
-          <p:cNvPr id="10" name="Text 7"/>
-          <p:cNvSpPr txBox="1"/>
-          <p:nvPr/>
-        </p:nvSpPr>
-        <p:spPr>
-          <a:xfrm>
-            <a:off x="6995160" y="2011680"/>
-            <a:ext cx="4480560" cy="658368"/>
-          </a:xfrm>
-          <a:prstGeom prst="rect">
-            <a:avLst/>
-          </a:prstGeom>
-          <a:noFill/>
-          <a:ln/>
-        </p:spPr>
-        <p:txBody>
-          <a:bodyPr wrap="square" lIns="0" tIns="0" rIns="0" bIns="0" rtlCol="0" anchor="ctr"/>
-          <a:lstStyle/>
-          <a:p>
-            <a:pPr indent="0" marL="0">
-              <a:buNone/>
-            </a:pPr>
-            <a:r>
-              <a:rPr lang="en-US" sz="1500" dirty="0">
+          <p:cNvPr id="7" name="Shape 3"/>
+          <p:cNvSpPr/>
+          <p:nvPr/>
+        </p:nvSpPr>
+        <p:spPr>
+          <a:xfrm>
+            <a:off x="5897880" y="1920240"/>
+            <a:ext cx="365760" cy="365760"/>
+          </a:xfrm>
+          <a:prstGeom prst="ellipse">
+            <a:avLst/>
+          </a:prstGeom>
+          <a:solidFill>
+            <a:srgbClr val="B3261E"/>
+          </a:solidFill>
+          <a:ln w="12700">
+            <a:solidFill>
+              <a:srgbClr val="B3261E"/>
+            </a:solidFill>
+            <a:prstDash val="solid"/>
+          </a:ln>
+        </p:spPr>
+      </p:sp>
+      <p:sp>
+        <p:nvSpPr>
+          <p:cNvPr id="8" name="Text 4"/>
+          <p:cNvSpPr txBox="1"/>
+          <p:nvPr/>
+        </p:nvSpPr>
+        <p:spPr>
+          <a:xfrm>
+            <a:off x="6446520" y="1463040"/>
+            <a:ext cx="5029200" cy="1280160"/>
+          </a:xfrm>
+          <a:prstGeom prst="rect">
+            <a:avLst/>
+          </a:prstGeom>
+          <a:noFill/>
+          <a:ln/>
+        </p:spPr>
+        <p:txBody>
+          <a:bodyPr wrap="square" lIns="0" tIns="0" rIns="0" bIns="0" rtlCol="0" anchor="ctr"/>
+          <a:lstStyle/>
+          <a:p>
+            <a:pPr indent="0" marL="0">
+              <a:buNone/>
+            </a:pPr>
+            <a:r>
+              <a:rPr lang="en-US" sz="1800" b="1" dirty="0">
+                <a:solidFill>
+                  <a:srgbClr val="B3261E"/>
+                </a:solidFill>
+              </a:rPr>
+              <a:t>Open</a:t>
+            </a:r>
+            <a:endParaRPr lang="en-US" sz="1800" dirty="0"/>
+          </a:p>
+          <a:p>
+            <a:pPr indent="0" marL="0">
+              <a:buNone/>
+            </a:pPr>
+            <a:r>
+              <a:rPr lang="en-US" sz="1300" dirty="0">
                 <a:solidFill>
                   <a:srgbClr val="2B1A1D"/>
                 </a:solidFill>
               </a:rPr>
-              <a:t>Apply migrations and seeds, then rehearse the demo</a:t>
-            </a:r>
-            <a:endParaRPr lang="en-US" sz="1500" dirty="0"/>
-          </a:p>
-        </p:txBody>
-      </p:sp>
-      <p:sp>
-        <p:nvSpPr>
-          <p:cNvPr id="11" name="Shape 8"/>
+              <a:t>No requirement is left open</a:t>
+            </a:r>
+            <a:endParaRPr lang="en-US" sz="1800" dirty="0"/>
+          </a:p>
+        </p:txBody>
+      </p:sp>
+      <p:sp>
+        <p:nvSpPr>
+          <p:cNvPr id="9" name="Shape 5"/>
           <p:cNvSpPr/>
           <p:nvPr/>
         </p:nvSpPr>
         <p:spPr>
           <a:xfrm>
-            <a:off x="6309360" y="2788920"/>
-            <a:ext cx="5303520" cy="658368"/>
+            <a:off x="5669280" y="2926080"/>
+            <a:ext cx="5943600" cy="1280160"/>
           </a:xfrm>
           <a:prstGeom prst="roundRect">
             <a:avLst>
-              <a:gd name="adj" fmla="val 16667"/>
+              <a:gd name="adj" fmla="val 8571"/>
             </a:avLst>
           </a:prstGeom>
           <a:solidFill>
@@ -6594,93 +6652,93 @@
       </p:sp>
       <p:sp>
         <p:nvSpPr>
-          <p:cNvPr id="12" name="Text 9"/>
-          <p:cNvSpPr txBox="1"/>
-          <p:nvPr/>
-        </p:nvSpPr>
-        <p:spPr>
-          <a:xfrm>
-            <a:off x="6446520" y="2788920"/>
-            <a:ext cx="457200" cy="658368"/>
-          </a:xfrm>
-          <a:prstGeom prst="rect">
-            <a:avLst/>
-          </a:prstGeom>
-          <a:noFill/>
-          <a:ln/>
-        </p:spPr>
-        <p:txBody>
-          <a:bodyPr wrap="square" lIns="0" tIns="0" rIns="0" bIns="0" rtlCol="0" anchor="ctr"/>
-          <a:lstStyle/>
-          <a:p>
-            <a:pPr indent="0" marL="0">
-              <a:buNone/>
-            </a:pPr>
-            <a:r>
-              <a:rPr lang="en-US" sz="2200" b="1" dirty="0">
-                <a:solidFill>
-                  <a:srgbClr val="D9A441"/>
-                </a:solidFill>
-                <a:latin typeface="Cambria" pitchFamily="34" charset="0"/>
-                <a:ea typeface="Cambria" pitchFamily="34" charset="-122"/>
-                <a:cs typeface="Cambria" pitchFamily="34" charset="-120"/>
-              </a:rPr>
-              <a:t>2</a:t>
-            </a:r>
-            <a:endParaRPr lang="en-US" sz="2200" dirty="0"/>
-          </a:p>
-        </p:txBody>
-      </p:sp>
-      <p:sp>
-        <p:nvSpPr>
-          <p:cNvPr id="13" name="Text 10"/>
-          <p:cNvSpPr txBox="1"/>
-          <p:nvPr/>
-        </p:nvSpPr>
-        <p:spPr>
-          <a:xfrm>
-            <a:off x="6995160" y="2788920"/>
-            <a:ext cx="4480560" cy="658368"/>
-          </a:xfrm>
-          <a:prstGeom prst="rect">
-            <a:avLst/>
-          </a:prstGeom>
-          <a:noFill/>
-          <a:ln/>
-        </p:spPr>
-        <p:txBody>
-          <a:bodyPr wrap="square" lIns="0" tIns="0" rIns="0" bIns="0" rtlCol="0" anchor="ctr"/>
-          <a:lstStyle/>
-          <a:p>
-            <a:pPr indent="0" marL="0">
-              <a:buNone/>
-            </a:pPr>
-            <a:r>
-              <a:rPr lang="en-US" sz="1500" dirty="0">
+          <p:cNvPr id="10" name="Shape 6"/>
+          <p:cNvSpPr/>
+          <p:nvPr/>
+        </p:nvSpPr>
+        <p:spPr>
+          <a:xfrm>
+            <a:off x="5897880" y="3383280"/>
+            <a:ext cx="365760" cy="365760"/>
+          </a:xfrm>
+          <a:prstGeom prst="ellipse">
+            <a:avLst/>
+          </a:prstGeom>
+          <a:solidFill>
+            <a:srgbClr val="C98A1B"/>
+          </a:solidFill>
+          <a:ln w="12700">
+            <a:solidFill>
+              <a:srgbClr val="C98A1B"/>
+            </a:solidFill>
+            <a:prstDash val="solid"/>
+          </a:ln>
+        </p:spPr>
+      </p:sp>
+      <p:sp>
+        <p:nvSpPr>
+          <p:cNvPr id="11" name="Text 7"/>
+          <p:cNvSpPr txBox="1"/>
+          <p:nvPr/>
+        </p:nvSpPr>
+        <p:spPr>
+          <a:xfrm>
+            <a:off x="6446520" y="2926080"/>
+            <a:ext cx="5029200" cy="1280160"/>
+          </a:xfrm>
+          <a:prstGeom prst="rect">
+            <a:avLst/>
+          </a:prstGeom>
+          <a:noFill/>
+          <a:ln/>
+        </p:spPr>
+        <p:txBody>
+          <a:bodyPr wrap="square" lIns="0" tIns="0" rIns="0" bIns="0" rtlCol="0" anchor="ctr"/>
+          <a:lstStyle/>
+          <a:p>
+            <a:pPr indent="0" marL="0">
+              <a:buNone/>
+            </a:pPr>
+            <a:r>
+              <a:rPr lang="en-US" sz="1800" b="1" dirty="0">
+                <a:solidFill>
+                  <a:srgbClr val="C98A1B"/>
+                </a:solidFill>
+              </a:rPr>
+              <a:t>Partial</a:t>
+            </a:r>
+            <a:endParaRPr lang="en-US" sz="1800" dirty="0"/>
+          </a:p>
+          <a:p>
+            <a:pPr indent="0" marL="0">
+              <a:buNone/>
+            </a:pPr>
+            <a:r>
+              <a:rPr lang="en-US" sz="1300" dirty="0">
                 <a:solidFill>
                   <a:srgbClr val="2B1A1D"/>
                 </a:solidFill>
               </a:rPr>
-              <a:t>Run the backtest on live data and publish the top-3 rate</a:t>
-            </a:r>
-            <a:endParaRPr lang="en-US" sz="1500" dirty="0"/>
-          </a:p>
-        </p:txBody>
-      </p:sp>
-      <p:sp>
-        <p:nvSpPr>
-          <p:cNvPr id="14" name="Shape 11"/>
+              <a:t>Faculty screen to pick several BU courses for one external course (API ready) · 5-credit lab rule (BU to answer)</a:t>
+            </a:r>
+            <a:endParaRPr lang="en-US" sz="1800" dirty="0"/>
+          </a:p>
+        </p:txBody>
+      </p:sp>
+      <p:sp>
+        <p:nvSpPr>
+          <p:cNvPr id="12" name="Shape 8"/>
           <p:cNvSpPr/>
           <p:nvPr/>
         </p:nvSpPr>
         <p:spPr>
           <a:xfrm>
-            <a:off x="6309360" y="3566160"/>
-            <a:ext cx="5303520" cy="658368"/>
+            <a:off x="5669280" y="4389120"/>
+            <a:ext cx="5943600" cy="1280160"/>
           </a:xfrm>
           <a:prstGeom prst="roundRect">
             <a:avLst>
-              <a:gd name="adj" fmla="val 16667"/>
+              <a:gd name="adj" fmla="val 8571"/>
             </a:avLst>
           </a:prstGeom>
           <a:solidFill>
@@ -6703,38 +6761,220 @@
       </p:sp>
       <p:sp>
         <p:nvSpPr>
-          <p:cNvPr id="15" name="Text 12"/>
-          <p:cNvSpPr txBox="1"/>
-          <p:nvPr/>
-        </p:nvSpPr>
-        <p:spPr>
-          <a:xfrm>
-            <a:off x="6446520" y="3566160"/>
-            <a:ext cx="457200" cy="658368"/>
-          </a:xfrm>
-          <a:prstGeom prst="rect">
-            <a:avLst/>
-          </a:prstGeom>
-          <a:noFill/>
-          <a:ln/>
-        </p:spPr>
-        <p:txBody>
-          <a:bodyPr wrap="square" lIns="0" tIns="0" rIns="0" bIns="0" rtlCol="0" anchor="ctr"/>
-          <a:lstStyle/>
-          <a:p>
-            <a:pPr indent="0" marL="0">
-              <a:buNone/>
-            </a:pPr>
-            <a:r>
-              <a:rPr lang="en-US" sz="2200" b="1" dirty="0">
-                <a:solidFill>
-                  <a:srgbClr val="D9A441"/>
+          <p:cNvPr id="13" name="Shape 9"/>
+          <p:cNvSpPr/>
+          <p:nvPr/>
+        </p:nvSpPr>
+        <p:spPr>
+          <a:xfrm>
+            <a:off x="5897880" y="4846320"/>
+            <a:ext cx="365760" cy="365760"/>
+          </a:xfrm>
+          <a:prstGeom prst="ellipse">
+            <a:avLst/>
+          </a:prstGeom>
+          <a:solidFill>
+            <a:srgbClr val="2F7D5B"/>
+          </a:solidFill>
+          <a:ln w="12700">
+            <a:solidFill>
+              <a:srgbClr val="2F7D5B"/>
+            </a:solidFill>
+            <a:prstDash val="solid"/>
+          </a:ln>
+        </p:spPr>
+      </p:sp>
+      <p:sp>
+        <p:nvSpPr>
+          <p:cNvPr id="14" name="Text 10"/>
+          <p:cNvSpPr txBox="1"/>
+          <p:nvPr/>
+        </p:nvSpPr>
+        <p:spPr>
+          <a:xfrm>
+            <a:off x="6446520" y="4389120"/>
+            <a:ext cx="5029200" cy="1280160"/>
+          </a:xfrm>
+          <a:prstGeom prst="rect">
+            <a:avLst/>
+          </a:prstGeom>
+          <a:noFill/>
+          <a:ln/>
+        </p:spPr>
+        <p:txBody>
+          <a:bodyPr wrap="square" lIns="0" tIns="0" rIns="0" bIns="0" rtlCol="0" anchor="ctr"/>
+          <a:lstStyle/>
+          <a:p>
+            <a:pPr indent="0" marL="0">
+              <a:buNone/>
+            </a:pPr>
+            <a:r>
+              <a:rPr lang="en-US" sz="1800" b="1" dirty="0">
+                <a:solidFill>
+                  <a:srgbClr val="2F7D5B"/>
+                </a:solidFill>
+              </a:rPr>
+              <a:t>Built</a:t>
+            </a:r>
+            <a:endParaRPr lang="en-US" sz="1800" dirty="0"/>
+          </a:p>
+          <a:p>
+            <a:pPr indent="0" marL="0">
+              <a:buNone/>
+            </a:pPr>
+            <a:r>
+              <a:rPr lang="en-US" sz="1300" dirty="0">
+                <a:solidFill>
+                  <a:srgbClr val="2B1A1D"/>
+                </a:solidFill>
+              </a:rPr>
+              <a:t>Lanes, quarter 2/3, grades, BU caps, Hub, appeals, workflow, learning loop, degree progress, side-by-side compare, programme rules, exam credit, one-year deadline, accuracy backtest, repeatable demo</a:t>
+            </a:r>
+            <a:endParaRPr lang="en-US" sz="1800" dirty="0"/>
+          </a:p>
+        </p:txBody>
+      </p:sp>
+    </p:spTree>
+  </p:cSld>
+  <p:clrMapOvr>
+    <a:masterClrMapping/>
+  </p:clrMapOvr>
+</p:sld>
+</file>
+
+<file path=ppt/slides/slide16.xml><?xml version="1.0" encoding="utf-8"?>
+<p:sld xmlns:a="http://schemas.openxmlformats.org/drawingml/2006/main" xmlns:r="http://schemas.openxmlformats.org/officeDocument/2006/relationships" xmlns:p="http://schemas.openxmlformats.org/presentationml/2006/main">
+  <p:cSld name="Slide 16">
+    <p:bg>
+      <p:bgPr>
+        <a:solidFill>
+          <a:srgbClr val="FFFFFF"/>
+        </a:solidFill>
+      </p:bgPr>
+    </p:bg>
+    <p:spTree>
+      <p:nvGrpSpPr>
+        <p:cNvPr id="1" name=""/>
+        <p:cNvGrpSpPr/>
+        <p:nvPr/>
+      </p:nvGrpSpPr>
+      <p:grpSpPr>
+        <a:xfrm>
+          <a:off x="0" y="0"/>
+          <a:ext cx="0" cy="0"/>
+          <a:chOff x="0" y="0"/>
+          <a:chExt cx="0" cy="0"/>
+        </a:xfrm>
+      </p:grpSpPr>
+      <p:sp>
+        <p:nvSpPr>
+          <p:cNvPr id="2" name="Text 0"/>
+          <p:cNvSpPr txBox="1"/>
+          <p:nvPr/>
+        </p:nvSpPr>
+        <p:spPr>
+          <a:xfrm>
+            <a:off x="548640" y="365760"/>
+            <a:ext cx="11064240" cy="822960"/>
+          </a:xfrm>
+          <a:prstGeom prst="rect">
+            <a:avLst/>
+          </a:prstGeom>
+          <a:noFill/>
+          <a:ln/>
+        </p:spPr>
+        <p:txBody>
+          <a:bodyPr wrap="square" lIns="0" tIns="0" rIns="0" bIns="0" rtlCol="0" anchor="ctr"/>
+          <a:lstStyle/>
+          <a:p>
+            <a:pPr indent="0" marL="0">
+              <a:buNone/>
+            </a:pPr>
+            <a:r>
+              <a:rPr lang="en-US" sz="3400" b="1" dirty="0">
+                <a:solidFill>
+                  <a:srgbClr val="770816"/>
                 </a:solidFill>
                 <a:latin typeface="Cambria" pitchFamily="34" charset="0"/>
                 <a:ea typeface="Cambria" pitchFamily="34" charset="-122"/>
                 <a:cs typeface="Cambria" pitchFamily="34" charset="-120"/>
               </a:rPr>
-              <a:t>3</a:t>
+              <a:t>What we have not proven yet, and what comes next</a:t>
+            </a:r>
+            <a:endParaRPr lang="en-US" sz="3400" dirty="0"/>
+          </a:p>
+        </p:txBody>
+      </p:sp>
+      <p:sp>
+        <p:nvSpPr>
+          <p:cNvPr id="4" name="Text 1"/>
+          <p:cNvSpPr txBox="1"/>
+          <p:nvPr/>
+        </p:nvSpPr>
+        <p:spPr>
+          <a:xfrm>
+            <a:off x="548640" y="6446520"/>
+            <a:ext cx="5486400" cy="274320"/>
+          </a:xfrm>
+          <a:prstGeom prst="rect">
+            <a:avLst/>
+          </a:prstGeom>
+          <a:noFill/>
+          <a:ln/>
+        </p:spPr>
+        <p:txBody>
+          <a:bodyPr wrap="square" lIns="0" tIns="0" rIns="0" bIns="0" rtlCol="0" anchor="ctr"/>
+          <a:lstStyle/>
+          <a:p>
+            <a:pPr indent="0" marL="0">
+              <a:buNone/>
+            </a:pPr>
+            <a:r>
+              <a:rPr lang="en-US" sz="1000" dirty="0">
+                <a:solidFill>
+                  <a:srgbClr val="6B5A5D"/>
+                </a:solidFill>
+              </a:rPr>
+              <a:t>TransferHub  ·  Clopay Code Crafters</a:t>
+            </a:r>
+            <a:endParaRPr lang="en-US" sz="1000" dirty="0"/>
+          </a:p>
+        </p:txBody>
+      </p:sp>
+      <p:sp>
+        <p:nvSpPr>
+          <p:cNvPr id="5" name="Text 2"/>
+          <p:cNvSpPr txBox="1"/>
+          <p:nvPr/>
+        </p:nvSpPr>
+        <p:spPr>
+          <a:xfrm>
+            <a:off x="548640" y="1417320"/>
+            <a:ext cx="5303520" cy="457200"/>
+          </a:xfrm>
+          <a:prstGeom prst="rect">
+            <a:avLst/>
+          </a:prstGeom>
+          <a:noFill/>
+          <a:ln/>
+        </p:spPr>
+        <p:txBody>
+          <a:bodyPr wrap="square" lIns="0" tIns="0" rIns="0" bIns="0" rtlCol="0" anchor="ctr"/>
+          <a:lstStyle/>
+          <a:p>
+            <a:pPr indent="0" marL="0">
+              <a:buNone/>
+            </a:pPr>
+            <a:r>
+              <a:rPr lang="en-US" sz="2200" b="1" dirty="0">
+                <a:solidFill>
+                  <a:srgbClr val="770816"/>
+                </a:solidFill>
+                <a:latin typeface="Cambria" pitchFamily="34" charset="0"/>
+                <a:ea typeface="Cambria" pitchFamily="34" charset="-122"/>
+                <a:cs typeface="Cambria" pitchFamily="34" charset="-120"/>
+              </a:rPr>
+              <a:t>Not proven yet</a:t>
             </a:r>
             <a:endParaRPr lang="en-US" sz="2200" dirty="0"/>
           </a:p>
@@ -6742,49 +6982,146 @@
       </p:sp>
       <p:sp>
         <p:nvSpPr>
-          <p:cNvPr id="16" name="Text 13"/>
-          <p:cNvSpPr txBox="1"/>
-          <p:nvPr/>
-        </p:nvSpPr>
-        <p:spPr>
-          <a:xfrm>
-            <a:off x="6995160" y="3566160"/>
-            <a:ext cx="4480560" cy="658368"/>
-          </a:xfrm>
-          <a:prstGeom prst="rect">
-            <a:avLst/>
-          </a:prstGeom>
-          <a:noFill/>
-          <a:ln/>
-        </p:spPr>
-        <p:txBody>
-          <a:bodyPr wrap="square" lIns="0" tIns="0" rIns="0" bIns="0" rtlCol="0" anchor="ctr"/>
-          <a:lstStyle/>
-          <a:p>
-            <a:pPr indent="0" marL="0">
-              <a:buNone/>
-            </a:pPr>
-            <a:r>
-              <a:rPr lang="en-US" sz="1500" dirty="0">
+          <p:cNvPr id="6" name="Text 3"/>
+          <p:cNvSpPr txBox="1"/>
+          <p:nvPr/>
+        </p:nvSpPr>
+        <p:spPr>
+          <a:xfrm>
+            <a:off x="548640" y="1965960"/>
+            <a:ext cx="5303520" cy="4023360"/>
+          </a:xfrm>
+          <a:prstGeom prst="rect">
+            <a:avLst/>
+          </a:prstGeom>
+          <a:noFill/>
+          <a:ln/>
+        </p:spPr>
+        <p:txBody>
+          <a:bodyPr wrap="square" lIns="0" tIns="0" rIns="0" bIns="0" rtlCol="0" anchor="t"/>
+          <a:lstStyle/>
+          <a:p>
+            <a:pPr marL="342900" indent="-342900">
+              <a:spcAft>
+                <a:spcPts val="1000"/>
+              </a:spcAft>
+              <a:buSzPct val="100000"/>
+              <a:buChar char="•"/>
+            </a:pPr>
+            <a:r>
+              <a:rPr lang="en-US" sz="1600" dirty="0">
                 <a:solidFill>
                   <a:srgbClr val="2B1A1D"/>
                 </a:solidFill>
               </a:rPr>
-              <a:t>Side-by-side course comparison</a:t>
-            </a:r>
-            <a:endParaRPr lang="en-US" sz="1500" dirty="0"/>
-          </a:p>
-        </p:txBody>
-      </p:sp>
-      <p:sp>
-        <p:nvSpPr>
-          <p:cNvPr id="17" name="Shape 14"/>
+              <a:t>No Anthropic key yet: AI paths are unverified, the rules fallback carries the demo</a:t>
+            </a:r>
+            <a:endParaRPr lang="en-US" sz="1600" dirty="0"/>
+          </a:p>
+          <a:p>
+            <a:pPr marL="342900" indent="-342900">
+              <a:spcAft>
+                <a:spcPts val="1000"/>
+              </a:spcAft>
+              <a:buSzPct val="100000"/>
+              <a:buChar char="•"/>
+            </a:pPr>
+            <a:r>
+              <a:rPr lang="en-US" sz="1600" dirty="0">
+                <a:solidFill>
+                  <a:srgbClr val="2B1A1D"/>
+                </a:solidFill>
+              </a:rPr>
+              <a:t>No BU baseline for evaluator minutes or turnaround, so the saving is not yet quantified</a:t>
+            </a:r>
+            <a:endParaRPr lang="en-US" sz="1600" dirty="0"/>
+          </a:p>
+          <a:p>
+            <a:pPr marL="342900" indent="-342900">
+              <a:spcAft>
+                <a:spcPts val="1000"/>
+              </a:spcAft>
+              <a:buSzPct val="100000"/>
+              <a:buChar char="•"/>
+            </a:pPr>
+            <a:r>
+              <a:rPr lang="en-US" sz="1600" dirty="0">
+                <a:solidFill>
+                  <a:srgbClr val="2B1A1D"/>
+                </a:solidFill>
+              </a:rPr>
+              <a:t>No API integration tests yet; coverage is unit tests, an HTTP smoke suite and SQL contract tests</a:t>
+            </a:r>
+            <a:endParaRPr lang="en-US" sz="1600" dirty="0"/>
+          </a:p>
+          <a:p>
+            <a:pPr marL="342900" indent="-342900">
+              <a:spcAft>
+                <a:spcPts val="1000"/>
+              </a:spcAft>
+              <a:buSzPct val="100000"/>
+              <a:buChar char="•"/>
+            </a:pPr>
+            <a:r>
+              <a:rPr lang="en-US" sz="1600" dirty="0">
+                <a:solidFill>
+                  <a:srgbClr val="2B1A1D"/>
+                </a:solidFill>
+              </a:rPr>
+              <a:t>Quarter rounding (2.66) follows the brief; BU to confirm</a:t>
+            </a:r>
+            <a:endParaRPr lang="en-US" sz="1600" dirty="0"/>
+          </a:p>
+        </p:txBody>
+      </p:sp>
+      <p:sp>
+        <p:nvSpPr>
+          <p:cNvPr id="7" name="Text 4"/>
+          <p:cNvSpPr txBox="1"/>
+          <p:nvPr/>
+        </p:nvSpPr>
+        <p:spPr>
+          <a:xfrm>
+            <a:off x="6309360" y="1417320"/>
+            <a:ext cx="5303520" cy="457200"/>
+          </a:xfrm>
+          <a:prstGeom prst="rect">
+            <a:avLst/>
+          </a:prstGeom>
+          <a:noFill/>
+          <a:ln/>
+        </p:spPr>
+        <p:txBody>
+          <a:bodyPr wrap="square" lIns="0" tIns="0" rIns="0" bIns="0" rtlCol="0" anchor="ctr"/>
+          <a:lstStyle/>
+          <a:p>
+            <a:pPr indent="0" marL="0">
+              <a:buNone/>
+            </a:pPr>
+            <a:r>
+              <a:rPr lang="en-US" sz="2200" b="1" dirty="0">
+                <a:solidFill>
+                  <a:srgbClr val="770816"/>
+                </a:solidFill>
+                <a:latin typeface="Cambria" pitchFamily="34" charset="0"/>
+                <a:ea typeface="Cambria" pitchFamily="34" charset="-122"/>
+                <a:cs typeface="Cambria" pitchFamily="34" charset="-120"/>
+              </a:rPr>
+              <a:t>Next</a:t>
+            </a:r>
+            <a:endParaRPr lang="en-US" sz="2200" dirty="0"/>
+          </a:p>
+        </p:txBody>
+      </p:sp>
+      <p:sp>
+        <p:nvSpPr>
+          <p:cNvPr id="8" name="Shape 5"/>
           <p:cNvSpPr/>
           <p:nvPr/>
         </p:nvSpPr>
         <p:spPr>
           <a:xfrm>
-            <a:off x="6309360" y="4343400"/>
+            <a:off x="6309360" y="2011680"/>
             <a:ext cx="5303520" cy="658368"/>
           </a:xfrm>
           <a:prstGeom prst="roundRect">
@@ -6812,13 +7149,13 @@
       </p:sp>
       <p:sp>
         <p:nvSpPr>
-          <p:cNvPr id="18" name="Text 15"/>
-          <p:cNvSpPr txBox="1"/>
-          <p:nvPr/>
-        </p:nvSpPr>
-        <p:spPr>
-          <a:xfrm>
-            <a:off x="6446520" y="4343400"/>
+          <p:cNvPr id="9" name="Text 6"/>
+          <p:cNvSpPr txBox="1"/>
+          <p:nvPr/>
+        </p:nvSpPr>
+        <p:spPr>
+          <a:xfrm>
+            <a:off x="6446520" y="2011680"/>
             <a:ext cx="457200" cy="658368"/>
           </a:xfrm>
           <a:prstGeom prst="rect">
@@ -6843,7 +7180,7 @@
                 <a:ea typeface="Cambria" pitchFamily="34" charset="-122"/>
                 <a:cs typeface="Cambria" pitchFamily="34" charset="-120"/>
               </a:rPr>
-              <a:t>4</a:t>
+              <a:t>1</a:t>
             </a:r>
             <a:endParaRPr lang="en-US" sz="2200" dirty="0"/>
           </a:p>
@@ -6851,13 +7188,13 @@
       </p:sp>
       <p:sp>
         <p:nvSpPr>
-          <p:cNvPr id="19" name="Text 16"/>
-          <p:cNvSpPr txBox="1"/>
-          <p:nvPr/>
-        </p:nvSpPr>
-        <p:spPr>
-          <a:xfrm>
-            <a:off x="6995160" y="4343400"/>
+          <p:cNvPr id="10" name="Text 7"/>
+          <p:cNvSpPr txBox="1"/>
+          <p:nvPr/>
+        </p:nvSpPr>
+        <p:spPr>
+          <a:xfrm>
+            <a:off x="6995160" y="2011680"/>
             <a:ext cx="4480560" cy="658368"/>
           </a:xfrm>
           <a:prstGeom prst="rect">
@@ -6879,7 +7216,7 @@
                   <a:srgbClr val="2B1A1D"/>
                 </a:solidFill>
               </a:rPr>
-              <a:t>One-year deadline and programme rules</a:t>
+              <a:t>Rehearse the demo from the Demo scenario page</a:t>
             </a:r>
             <a:endParaRPr lang="en-US" sz="1500" dirty="0"/>
           </a:p>
@@ -6887,13 +7224,13 @@
       </p:sp>
       <p:sp>
         <p:nvSpPr>
-          <p:cNvPr id="20" name="Shape 17"/>
+          <p:cNvPr id="11" name="Shape 8"/>
           <p:cNvSpPr/>
           <p:nvPr/>
         </p:nvSpPr>
         <p:spPr>
           <a:xfrm>
-            <a:off x="6309360" y="5120640"/>
+            <a:off x="6309360" y="2788920"/>
             <a:ext cx="5303520" cy="658368"/>
           </a:xfrm>
           <a:prstGeom prst="roundRect">
@@ -6921,13 +7258,13 @@
       </p:sp>
       <p:sp>
         <p:nvSpPr>
-          <p:cNvPr id="21" name="Text 18"/>
-          <p:cNvSpPr txBox="1"/>
-          <p:nvPr/>
-        </p:nvSpPr>
-        <p:spPr>
-          <a:xfrm>
-            <a:off x="6446520" y="5120640"/>
+          <p:cNvPr id="12" name="Text 9"/>
+          <p:cNvSpPr txBox="1"/>
+          <p:nvPr/>
+        </p:nvSpPr>
+        <p:spPr>
+          <a:xfrm>
+            <a:off x="6446520" y="2788920"/>
             <a:ext cx="457200" cy="658368"/>
           </a:xfrm>
           <a:prstGeom prst="rect">
@@ -6952,6 +7289,333 @@
                 <a:ea typeface="Cambria" pitchFamily="34" charset="-122"/>
                 <a:cs typeface="Cambria" pitchFamily="34" charset="-120"/>
               </a:rPr>
+              <a:t>2</a:t>
+            </a:r>
+            <a:endParaRPr lang="en-US" sz="2200" dirty="0"/>
+          </a:p>
+        </p:txBody>
+      </p:sp>
+      <p:sp>
+        <p:nvSpPr>
+          <p:cNvPr id="13" name="Text 10"/>
+          <p:cNvSpPr txBox="1"/>
+          <p:nvPr/>
+        </p:nvSpPr>
+        <p:spPr>
+          <a:xfrm>
+            <a:off x="6995160" y="2788920"/>
+            <a:ext cx="4480560" cy="658368"/>
+          </a:xfrm>
+          <a:prstGeom prst="rect">
+            <a:avLst/>
+          </a:prstGeom>
+          <a:noFill/>
+          <a:ln/>
+        </p:spPr>
+        <p:txBody>
+          <a:bodyPr wrap="square" lIns="0" tIns="0" rIns="0" bIns="0" rtlCol="0" anchor="ctr"/>
+          <a:lstStyle/>
+          <a:p>
+            <a:pPr indent="0" marL="0">
+              <a:buNone/>
+            </a:pPr>
+            <a:r>
+              <a:rPr lang="en-US" sz="1500" dirty="0">
+                <a:solidFill>
+                  <a:srgbClr val="2B1A1D"/>
+                </a:solidFill>
+              </a:rPr>
+              <a:t>Get BU answers: 5-credit lab rule, rounding, AP/IB minimums</a:t>
+            </a:r>
+            <a:endParaRPr lang="en-US" sz="1500" dirty="0"/>
+          </a:p>
+        </p:txBody>
+      </p:sp>
+      <p:sp>
+        <p:nvSpPr>
+          <p:cNvPr id="14" name="Shape 11"/>
+          <p:cNvSpPr/>
+          <p:nvPr/>
+        </p:nvSpPr>
+        <p:spPr>
+          <a:xfrm>
+            <a:off x="6309360" y="3566160"/>
+            <a:ext cx="5303520" cy="658368"/>
+          </a:xfrm>
+          <a:prstGeom prst="roundRect">
+            <a:avLst>
+              <a:gd name="adj" fmla="val 16667"/>
+            </a:avLst>
+          </a:prstGeom>
+          <a:solidFill>
+            <a:srgbClr val="FDF2F3"/>
+          </a:solidFill>
+          <a:ln w="12700">
+            <a:solidFill>
+              <a:srgbClr val="FDF2F3"/>
+            </a:solidFill>
+            <a:prstDash val="solid"/>
+          </a:ln>
+          <a:effectLst>
+            <a:outerShdw sx="100000" sy="100000" kx="0" ky="0" algn="bl" rotWithShape="0" blurRad="101600" dist="25400" dir="5400000">
+              <a:srgbClr val="000000">
+                <a:alpha val="8000"/>
+              </a:srgbClr>
+            </a:outerShdw>
+          </a:effectLst>
+        </p:spPr>
+      </p:sp>
+      <p:sp>
+        <p:nvSpPr>
+          <p:cNvPr id="15" name="Text 12"/>
+          <p:cNvSpPr txBox="1"/>
+          <p:nvPr/>
+        </p:nvSpPr>
+        <p:spPr>
+          <a:xfrm>
+            <a:off x="6446520" y="3566160"/>
+            <a:ext cx="457200" cy="658368"/>
+          </a:xfrm>
+          <a:prstGeom prst="rect">
+            <a:avLst/>
+          </a:prstGeom>
+          <a:noFill/>
+          <a:ln/>
+        </p:spPr>
+        <p:txBody>
+          <a:bodyPr wrap="square" lIns="0" tIns="0" rIns="0" bIns="0" rtlCol="0" anchor="ctr"/>
+          <a:lstStyle/>
+          <a:p>
+            <a:pPr indent="0" marL="0">
+              <a:buNone/>
+            </a:pPr>
+            <a:r>
+              <a:rPr lang="en-US" sz="2200" b="1" dirty="0">
+                <a:solidFill>
+                  <a:srgbClr val="D9A441"/>
+                </a:solidFill>
+                <a:latin typeface="Cambria" pitchFamily="34" charset="0"/>
+                <a:ea typeface="Cambria" pitchFamily="34" charset="-122"/>
+                <a:cs typeface="Cambria" pitchFamily="34" charset="-120"/>
+              </a:rPr>
+              <a:t>3</a:t>
+            </a:r>
+            <a:endParaRPr lang="en-US" sz="2200" dirty="0"/>
+          </a:p>
+        </p:txBody>
+      </p:sp>
+      <p:sp>
+        <p:nvSpPr>
+          <p:cNvPr id="16" name="Text 13"/>
+          <p:cNvSpPr txBox="1"/>
+          <p:nvPr/>
+        </p:nvSpPr>
+        <p:spPr>
+          <a:xfrm>
+            <a:off x="6995160" y="3566160"/>
+            <a:ext cx="4480560" cy="658368"/>
+          </a:xfrm>
+          <a:prstGeom prst="rect">
+            <a:avLst/>
+          </a:prstGeom>
+          <a:noFill/>
+          <a:ln/>
+        </p:spPr>
+        <p:txBody>
+          <a:bodyPr wrap="square" lIns="0" tIns="0" rIns="0" bIns="0" rtlCol="0" anchor="ctr"/>
+          <a:lstStyle/>
+          <a:p>
+            <a:pPr indent="0" marL="0">
+              <a:buNone/>
+            </a:pPr>
+            <a:r>
+              <a:rPr lang="en-US" sz="1500" dirty="0">
+                <a:solidFill>
+                  <a:srgbClr val="2B1A1D"/>
+                </a:solidFill>
+              </a:rPr>
+              <a:t>Faculty screen for one-to-many course mappings</a:t>
+            </a:r>
+            <a:endParaRPr lang="en-US" sz="1500" dirty="0"/>
+          </a:p>
+        </p:txBody>
+      </p:sp>
+      <p:sp>
+        <p:nvSpPr>
+          <p:cNvPr id="17" name="Shape 14"/>
+          <p:cNvSpPr/>
+          <p:nvPr/>
+        </p:nvSpPr>
+        <p:spPr>
+          <a:xfrm>
+            <a:off x="6309360" y="4343400"/>
+            <a:ext cx="5303520" cy="658368"/>
+          </a:xfrm>
+          <a:prstGeom prst="roundRect">
+            <a:avLst>
+              <a:gd name="adj" fmla="val 16667"/>
+            </a:avLst>
+          </a:prstGeom>
+          <a:solidFill>
+            <a:srgbClr val="FDF2F3"/>
+          </a:solidFill>
+          <a:ln w="12700">
+            <a:solidFill>
+              <a:srgbClr val="FDF2F3"/>
+            </a:solidFill>
+            <a:prstDash val="solid"/>
+          </a:ln>
+          <a:effectLst>
+            <a:outerShdw sx="100000" sy="100000" kx="0" ky="0" algn="bl" rotWithShape="0" blurRad="101600" dist="25400" dir="5400000">
+              <a:srgbClr val="000000">
+                <a:alpha val="8000"/>
+              </a:srgbClr>
+            </a:outerShdw>
+          </a:effectLst>
+        </p:spPr>
+      </p:sp>
+      <p:sp>
+        <p:nvSpPr>
+          <p:cNvPr id="18" name="Text 15"/>
+          <p:cNvSpPr txBox="1"/>
+          <p:nvPr/>
+        </p:nvSpPr>
+        <p:spPr>
+          <a:xfrm>
+            <a:off x="6446520" y="4343400"/>
+            <a:ext cx="457200" cy="658368"/>
+          </a:xfrm>
+          <a:prstGeom prst="rect">
+            <a:avLst/>
+          </a:prstGeom>
+          <a:noFill/>
+          <a:ln/>
+        </p:spPr>
+        <p:txBody>
+          <a:bodyPr wrap="square" lIns="0" tIns="0" rIns="0" bIns="0" rtlCol="0" anchor="ctr"/>
+          <a:lstStyle/>
+          <a:p>
+            <a:pPr indent="0" marL="0">
+              <a:buNone/>
+            </a:pPr>
+            <a:r>
+              <a:rPr lang="en-US" sz="2200" b="1" dirty="0">
+                <a:solidFill>
+                  <a:srgbClr val="D9A441"/>
+                </a:solidFill>
+                <a:latin typeface="Cambria" pitchFamily="34" charset="0"/>
+                <a:ea typeface="Cambria" pitchFamily="34" charset="-122"/>
+                <a:cs typeface="Cambria" pitchFamily="34" charset="-120"/>
+              </a:rPr>
+              <a:t>4</a:t>
+            </a:r>
+            <a:endParaRPr lang="en-US" sz="2200" dirty="0"/>
+          </a:p>
+        </p:txBody>
+      </p:sp>
+      <p:sp>
+        <p:nvSpPr>
+          <p:cNvPr id="19" name="Text 16"/>
+          <p:cNvSpPr txBox="1"/>
+          <p:nvPr/>
+        </p:nvSpPr>
+        <p:spPr>
+          <a:xfrm>
+            <a:off x="6995160" y="4343400"/>
+            <a:ext cx="4480560" cy="658368"/>
+          </a:xfrm>
+          <a:prstGeom prst="rect">
+            <a:avLst/>
+          </a:prstGeom>
+          <a:noFill/>
+          <a:ln/>
+        </p:spPr>
+        <p:txBody>
+          <a:bodyPr wrap="square" lIns="0" tIns="0" rIns="0" bIns="0" rtlCol="0" anchor="ctr"/>
+          <a:lstStyle/>
+          <a:p>
+            <a:pPr indent="0" marL="0">
+              <a:buNone/>
+            </a:pPr>
+            <a:r>
+              <a:rPr lang="en-US" sz="1500" dirty="0">
+                <a:solidFill>
+                  <a:srgbClr val="2B1A1D"/>
+                </a:solidFill>
+              </a:rPr>
+              <a:t>Turn on Claude and re-run the same backtest</a:t>
+            </a:r>
+            <a:endParaRPr lang="en-US" sz="1500" dirty="0"/>
+          </a:p>
+        </p:txBody>
+      </p:sp>
+      <p:sp>
+        <p:nvSpPr>
+          <p:cNvPr id="20" name="Shape 17"/>
+          <p:cNvSpPr/>
+          <p:nvPr/>
+        </p:nvSpPr>
+        <p:spPr>
+          <a:xfrm>
+            <a:off x="6309360" y="5120640"/>
+            <a:ext cx="5303520" cy="658368"/>
+          </a:xfrm>
+          <a:prstGeom prst="roundRect">
+            <a:avLst>
+              <a:gd name="adj" fmla="val 16667"/>
+            </a:avLst>
+          </a:prstGeom>
+          <a:solidFill>
+            <a:srgbClr val="FDF2F3"/>
+          </a:solidFill>
+          <a:ln w="12700">
+            <a:solidFill>
+              <a:srgbClr val="FDF2F3"/>
+            </a:solidFill>
+            <a:prstDash val="solid"/>
+          </a:ln>
+          <a:effectLst>
+            <a:outerShdw sx="100000" sy="100000" kx="0" ky="0" algn="bl" rotWithShape="0" blurRad="101600" dist="25400" dir="5400000">
+              <a:srgbClr val="000000">
+                <a:alpha val="8000"/>
+              </a:srgbClr>
+            </a:outerShdw>
+          </a:effectLst>
+        </p:spPr>
+      </p:sp>
+      <p:sp>
+        <p:nvSpPr>
+          <p:cNvPr id="21" name="Text 18"/>
+          <p:cNvSpPr txBox="1"/>
+          <p:nvPr/>
+        </p:nvSpPr>
+        <p:spPr>
+          <a:xfrm>
+            <a:off x="6446520" y="5120640"/>
+            <a:ext cx="457200" cy="658368"/>
+          </a:xfrm>
+          <a:prstGeom prst="rect">
+            <a:avLst/>
+          </a:prstGeom>
+          <a:noFill/>
+          <a:ln/>
+        </p:spPr>
+        <p:txBody>
+          <a:bodyPr wrap="square" lIns="0" tIns="0" rIns="0" bIns="0" rtlCol="0" anchor="ctr"/>
+          <a:lstStyle/>
+          <a:p>
+            <a:pPr indent="0" marL="0">
+              <a:buNone/>
+            </a:pPr>
+            <a:r>
+              <a:rPr lang="en-US" sz="2200" b="1" dirty="0">
+                <a:solidFill>
+                  <a:srgbClr val="D9A441"/>
+                </a:solidFill>
+                <a:latin typeface="Cambria" pitchFamily="34" charset="0"/>
+                <a:ea typeface="Cambria" pitchFamily="34" charset="-122"/>
+                <a:cs typeface="Cambria" pitchFamily="34" charset="-120"/>
+              </a:rPr>
               <a:t>5</a:t>
             </a:r>
             <a:endParaRPr lang="en-US" sz="2200" dirty="0"/>
@@ -6988,7 +7652,7 @@
                   <a:srgbClr val="2B1A1D"/>
                 </a:solidFill>
               </a:rPr>
-              <a:t>Turn on Claude and measure</a:t>
+              <a:t>Measure evaluator minutes against a BU baseline</a:t>
             </a:r>
             <a:endParaRPr lang="en-US" sz="1500" dirty="0"/>
           </a:p>
@@ -7002,9 +7666,9 @@
 </p:sld>
 </file>
 
-<file path=ppt/slides/slide16.xml><?xml version="1.0" encoding="utf-8"?>
+<file path=ppt/slides/slide17.xml><?xml version="1.0" encoding="utf-8"?>
 <p:sld xmlns:a="http://schemas.openxmlformats.org/drawingml/2006/main" xmlns:r="http://schemas.openxmlformats.org/officeDocument/2006/relationships" xmlns:p="http://schemas.openxmlformats.org/presentationml/2006/main">
-  <p:cSld name="Slide 16">
+  <p:cSld name="Slide 17">
     <p:bg>
       <p:bgPr>
         <a:solidFill>

</xml_diff>